<commit_message>
S3: Enrich speaker notes — accuracy patterns, security, multiplier quote
- 5 Mistakes: added 4 specific accuracy issues (fake stats, generic recs, outdated info, optimistic phrasing) + biotech gene therapy example
- Closing: 'AI doesn't replace expertise, it multiplies it. Mediocre faster vs superpowers.'
- Integration: data privacy/security callout for IT teams
Notes-only updates, no new slides. 41 slides unchanged.
</commit_message>
<xml_diff>
--- a/slides/Business Users/S3_PowerPoint_Executive.pptx
+++ b/slides/Business Users/S3_PowerPoint_Executive.pptx
@@ -2560,7 +2560,7 @@
           </a:p>
           <a:p>
             <a:r>
-              <a:t>   * Mistake two: not reviewing output. AI is brilliant at structure and mediocre at facts. A real example — a banking client's AI-generated slide confidently stated 'European fintech funding increased 43 percent in Q3.' Impressive. Also completely fabricated. The actual number was 12 percent. If they'd presented that to investors, their credibility would have been destroyed.</a:t>
+              <a:t>   * Mistake two: not reviewing output. AI is brilliant at structure and mediocre at facts. A real example — a banking client's AI-generated slide confidently stated 'European fintech funding increased 43 percent in Q3.' Impressive. Also completely fabricated. The actual number was 12 percent. If they'd presented that to investors, their credibility would have been destroyed. Watch for four specific patterns: inventing plausible-sounding statistics, generic recommendations that lack your business context, outdated information from training data lag, and overly optimistic phrasing that lacks nuance. A biotech client asked AI to explain their gene therapy mechanism — the structure was excellent, but the science was oversimplified to the point of inaccuracy. They kept the structure and replaced all the scientific content. That's the right approach.</a:t>
             </a:r>
           </a:p>
           <a:p>
@@ -4748,6 +4748,11 @@
               <a:t>   * The best presenters aren't the ones with the prettiest slides — they're the ones with the clearest thinking</a:t>
             </a:r>
           </a:p>
+          <a:p>
+            <a:r>
+              <a:t>   * One more thing to remember: AI doesn't replace expertise. It multiplies it. If you're mediocre at presentations, AI makes you mediocre faster. If you're skilled at presentations, AI gives you superpowers. The people who invest 2 to 3 hours learning these techniques save 3 to 4 hours per deck for the rest of their careers. That's not a trade-off — that's leverage.</a:t>
+            </a:r>
+          </a:p>
           <a:p/>
           <a:p>
             <a:r>
@@ -4861,6 +4866,11 @@
               <a:t>   * Questions? I'm available after the session for one-on-one help.</a:t>
             </a:r>
           </a:p>
+          <a:p>
+            <a:r>
+              <a:t>   * One more thing to remember: AI doesn't replace expertise. It multiplies it. If you're mediocre at presentations, AI makes you mediocre faster. If you're skilled at presentations, AI gives you superpowers. The people who invest 2 to 3 hours learning these techniques save 3 to 4 hours per deck for the rest of their careers. That's not a trade-off — that's leverage.</a:t>
+            </a:r>
+          </a:p>
         </p:txBody>
       </p:sp>
       <p:sp>
@@ -5113,6 +5123,11 @@
               <a:t>   * The Research Preview will improve rapidly — Microsoft and Anthropic are actively developing this</a:t>
             </a:r>
           </a:p>
+          <a:p>
+            <a:r>
+              <a:t>   * Quick note on security that your IT team will ask about: Claude does not train on your content. Your data stays private. That said, always verify your organization's data governance policies before using AI with sensitive presentations — especially investor materials, M&amp;A decks, or anything with material non-public information.</a:t>
+            </a:r>
+          </a:p>
           <a:p/>
           <a:p>
             <a:r>
@@ -5245,6 +5260,11 @@
           <a:p>
             <a:r>
               <a:t>   * Speaker notes generation alone saves 30-60 minutes per deck</a:t>
+            </a:r>
+          </a:p>
+          <a:p>
+            <a:r>
+              <a:t>   * Quick note on security that your IT team will ask about: Claude does not train on your content. Your data stays private. That said, always verify your organization's data governance policies before using AI with sensitive presentations — especially investor materials, M&amp;A decks, or anything with material non-public information.</a:t>
             </a:r>
           </a:p>
           <a:p/>

</xml_diff>